<commit_message>
tweaked a couple of slides, fixed font size
</commit_message>
<xml_diff>
--- a/Slides/Module 03 Unit Testing.pptx
+++ b/Slides/Module 03 Unit Testing.pptx
@@ -322,7 +322,7 @@
           <a:p>
             <a:fld id="{7C7E5181-6CF5-45F7-A87A-E0E0B1FD7549}" type="datetimeFigureOut">
               <a:rPr lang="en-US" smtClean="0"/>
-              <a:t>8/11/2026</a:t>
+              <a:t>8/17/2026</a:t>
             </a:fld>
             <a:endParaRPr lang="en-US"/>
           </a:p>
@@ -4893,7 +4893,7 @@
           <a:p>
             <a:fld id="{5D2A64DE-480B-420F-9649-4F8E696E08E0}" type="datetime1">
               <a:rPr lang="en-US" smtClean="0"/>
-              <a:t>8/11/2026</a:t>
+              <a:t>8/17/2026</a:t>
             </a:fld>
             <a:endParaRPr lang="en-US"/>
           </a:p>
@@ -5217,7 +5217,7 @@
           <a:p>
             <a:fld id="{EA476A42-A091-4468-A075-64A31BE59948}" type="datetime1">
               <a:rPr lang="en-US" smtClean="0"/>
-              <a:t>8/11/2026</a:t>
+              <a:t>8/17/2026</a:t>
             </a:fld>
             <a:endParaRPr lang="en-US"/>
           </a:p>
@@ -5415,7 +5415,7 @@
           <a:p>
             <a:fld id="{0D3616D0-8311-4107-9726-6B805E7D05BA}" type="datetime1">
               <a:rPr lang="en-US" smtClean="0"/>
-              <a:t>8/11/2026</a:t>
+              <a:t>8/17/2026</a:t>
             </a:fld>
             <a:endParaRPr lang="en-US"/>
           </a:p>
@@ -5623,7 +5623,7 @@
           <a:p>
             <a:fld id="{3BC2557A-5C88-417A-A763-5AC779462A5F}" type="datetime1">
               <a:rPr lang="en-US" smtClean="0"/>
-              <a:t>8/11/2026</a:t>
+              <a:t>8/17/2026</a:t>
             </a:fld>
             <a:endParaRPr lang="en-US"/>
           </a:p>
@@ -6045,7 +6045,7 @@
           <a:p>
             <a:fld id="{07C7BFD4-467E-4EDE-93EA-052F5B39A4E5}" type="datetime1">
               <a:rPr lang="en-US" smtClean="0"/>
-              <a:t>8/11/2026</a:t>
+              <a:t>8/17/2026</a:t>
             </a:fld>
             <a:endParaRPr lang="en-US"/>
           </a:p>
@@ -6295,7 +6295,7 @@
           <a:p>
             <a:fld id="{07C7BFD4-467E-4EDE-93EA-052F5B39A4E5}" type="datetime1">
               <a:rPr lang="en-US" smtClean="0"/>
-              <a:t>8/11/2026</a:t>
+              <a:t>8/17/2026</a:t>
             </a:fld>
             <a:endParaRPr lang="en-US"/>
           </a:p>
@@ -6477,7 +6477,7 @@
           <a:p>
             <a:fld id="{109E55A0-C911-4F03-82FC-7E5926047D46}" type="datetime1">
               <a:rPr lang="en-US" smtClean="0"/>
-              <a:t>8/11/2026</a:t>
+              <a:t>8/17/2026</a:t>
             </a:fld>
             <a:endParaRPr lang="en-US"/>
           </a:p>
@@ -6790,7 +6790,7 @@
           <a:p>
             <a:fld id="{A533CBE2-D5BE-47AC-ADC2-9CDFC1D0CF90}" type="datetime1">
               <a:rPr lang="en-US" smtClean="0"/>
-              <a:t>8/11/2026</a:t>
+              <a:t>8/17/2026</a:t>
             </a:fld>
             <a:endParaRPr lang="en-US"/>
           </a:p>
@@ -7091,7 +7091,7 @@
           <a:p>
             <a:fld id="{39B7EDB1-CE74-4951-85A2-0B01C2128E28}" type="datetime1">
               <a:rPr lang="en-US" smtClean="0"/>
-              <a:t>8/11/2026</a:t>
+              <a:t>8/17/2026</a:t>
             </a:fld>
             <a:endParaRPr lang="en-US"/>
           </a:p>
@@ -7539,7 +7539,7 @@
           <a:p>
             <a:fld id="{2BC7EB92-A5C2-4807-A9DC-9EDE6CBFB241}" type="datetime1">
               <a:rPr lang="en-US" smtClean="0"/>
-              <a:t>8/11/2026</a:t>
+              <a:t>8/17/2026</a:t>
             </a:fld>
             <a:endParaRPr lang="en-US"/>
           </a:p>
@@ -7652,7 +7652,7 @@
           <a:p>
             <a:fld id="{2B7B7EE0-7771-4CD5-9B2B-3550753A54A1}" type="datetime1">
               <a:rPr lang="en-US" smtClean="0"/>
-              <a:t>8/11/2026</a:t>
+              <a:t>8/17/2026</a:t>
             </a:fld>
             <a:endParaRPr lang="en-US"/>
           </a:p>
@@ -7963,7 +7963,7 @@
           <a:p>
             <a:fld id="{F8B318B3-0E87-4416-A9B8-D891968C2727}" type="datetime1">
               <a:rPr lang="en-US" smtClean="0"/>
-              <a:t>8/11/2026</a:t>
+              <a:t>8/17/2026</a:t>
             </a:fld>
             <a:endParaRPr lang="en-US"/>
           </a:p>
@@ -8204,7 +8204,7 @@
           <a:p>
             <a:fld id="{54D997E8-DDEE-43F1-8D9B-F8A1E11DE488}" type="datetime1">
               <a:rPr lang="en-US" smtClean="0"/>
-              <a:t>8/11/2026</a:t>
+              <a:t>8/17/2026</a:t>
             </a:fld>
             <a:endParaRPr lang="en-US"/>
           </a:p>
@@ -14297,11 +14297,13 @@
         </p:nvSpPr>
         <p:spPr/>
         <p:txBody>
-          <a:bodyPr/>
+          <a:bodyPr>
+            <a:normAutofit/>
+          </a:bodyPr>
           <a:lstStyle/>
           <a:p>
             <a:r>
-              <a:rPr lang="en-US" dirty="0"/>
+              <a:rPr lang="en-US" sz="3600" dirty="0"/>
               <a:t>Property-based tests can specify a range of inputs</a:t>
             </a:r>
           </a:p>
@@ -15983,7 +15985,12 @@
             <p:ph idx="1"/>
           </p:nvPr>
         </p:nvSpPr>
-        <p:spPr/>
+        <p:spPr>
+          <a:xfrm>
+            <a:off x="838200" y="1500160"/>
+            <a:ext cx="9242502" cy="4351338"/>
+          </a:xfrm>
+        </p:spPr>
         <p:txBody>
           <a:bodyPr/>
           <a:lstStyle/>
@@ -16074,7 +16081,7 @@
           <a:p>
             <a:r>
               <a:rPr lang="en-US" dirty="0"/>
-              <a:t>3.1 Have we tested enough of the code?</a:t>
+              <a:t>3.2 Have we tested enough of the code?</a:t>
             </a:r>
           </a:p>
         </p:txBody>
@@ -16095,7 +16102,12 @@
             <p:ph idx="1"/>
           </p:nvPr>
         </p:nvSpPr>
-        <p:spPr/>
+        <p:spPr>
+          <a:xfrm>
+            <a:off x="838200" y="1500160"/>
+            <a:ext cx="9197898" cy="4351338"/>
+          </a:xfrm>
+        </p:spPr>
         <p:txBody>
           <a:bodyPr/>
           <a:lstStyle/>
@@ -17600,7 +17612,7 @@
           <a:lstStyle/>
           <a:p>
             <a:r>
-              <a:rPr lang="en-US"/>
+              <a:rPr lang="en-US" dirty="0"/>
               <a:t>Learning Goals for this Lesson</a:t>
             </a:r>
           </a:p>
@@ -22747,7 +22759,7 @@
           <a:p>
             <a:r>
               <a:rPr lang="en-US" dirty="0"/>
-              <a:t>Code Coverage: Review</a:t>
+              <a:t>Review of Section 3.2</a:t>
             </a:r>
           </a:p>
         </p:txBody>
@@ -22938,7 +22950,12 @@
             <p:ph idx="1"/>
           </p:nvPr>
         </p:nvSpPr>
-        <p:spPr/>
+        <p:spPr>
+          <a:xfrm>
+            <a:off x="838199" y="1500160"/>
+            <a:ext cx="9175595" cy="4351338"/>
+          </a:xfrm>
+        </p:spPr>
         <p:txBody>
           <a:bodyPr/>
           <a:lstStyle/>
@@ -23397,8 +23414,15 @@
           <a:p>
             <a:r>
               <a:rPr lang="en-US" b="1" dirty="0"/>
-              <a:t>Integration Tests</a:t>
-            </a:r>
+              <a:t>Integration Tests: </a:t>
+            </a:r>
+            <a:r>
+              <a:rPr lang="en-US" dirty="0"/>
+              <a:t>testing more than a single unit</a:t>
+            </a:r>
+          </a:p>
+          <a:p>
+            <a:pPr lvl="1"/>
             <a:r>
               <a:rPr lang="en-US" dirty="0"/>
               <a:t> test how parts of a program work together: that’s where we ensure </a:t>
@@ -23643,7 +23667,7 @@
           </a:ln>
           <a:extLst>
             <a:ext uri="{C572A759-6A51-4108-AA02-DFA0A04FC94B}">
-              <ma14:wrappingTextBoxFlag xmlns:ma14="http://schemas.microsoft.com/office/mac/drawingml/2011/main" xmlns:a14="http://schemas.microsoft.com/office/drawing/2010/main" xmlns:m="http://schemas.openxmlformats.org/officeDocument/2006/math" xmlns="" val="1"/>
+              <ma14:wrappingTextBoxFlag xmlns="" xmlns:m="http://schemas.openxmlformats.org/officeDocument/2006/math" xmlns:a14="http://schemas.microsoft.com/office/drawing/2010/main" xmlns:ma14="http://schemas.microsoft.com/office/mac/drawingml/2011/main" val="1"/>
             </a:ext>
           </a:extLst>
         </p:spPr>
@@ -23981,7 +24005,7 @@
           </a:ln>
           <a:extLst>
             <a:ext uri="{C572A759-6A51-4108-AA02-DFA0A04FC94B}">
-              <ma14:wrappingTextBoxFlag xmlns:ma14="http://schemas.microsoft.com/office/mac/drawingml/2011/main" xmlns:a14="http://schemas.microsoft.com/office/drawing/2010/main" xmlns:m="http://schemas.openxmlformats.org/officeDocument/2006/math" xmlns="" val="1"/>
+              <ma14:wrappingTextBoxFlag xmlns="" xmlns:m="http://schemas.openxmlformats.org/officeDocument/2006/math" xmlns:a14="http://schemas.microsoft.com/office/drawing/2010/main" xmlns:ma14="http://schemas.microsoft.com/office/mac/drawingml/2011/main" val="1"/>
             </a:ext>
           </a:extLst>
         </p:spPr>
@@ -24406,7 +24430,7 @@
           </a:ln>
           <a:extLst>
             <a:ext uri="{C572A759-6A51-4108-AA02-DFA0A04FC94B}">
-              <ma14:wrappingTextBoxFlag xmlns:ma14="http://schemas.microsoft.com/office/mac/drawingml/2011/main" xmlns:a14="http://schemas.microsoft.com/office/drawing/2010/main" xmlns:m="http://schemas.openxmlformats.org/officeDocument/2006/math" xmlns="" val="1"/>
+              <ma14:wrappingTextBoxFlag xmlns="" xmlns:m="http://schemas.openxmlformats.org/officeDocument/2006/math" xmlns:a14="http://schemas.microsoft.com/office/drawing/2010/main" xmlns:ma14="http://schemas.microsoft.com/office/mac/drawingml/2011/main" val="1"/>
             </a:ext>
           </a:extLst>
         </p:spPr>
@@ -24443,7 +24467,7 @@
           </a:ln>
           <a:extLst>
             <a:ext uri="{C572A759-6A51-4108-AA02-DFA0A04FC94B}">
-              <ma14:wrappingTextBoxFlag xmlns:ma14="http://schemas.microsoft.com/office/mac/drawingml/2011/main" xmlns:a14="http://schemas.microsoft.com/office/drawing/2010/main" xmlns:m="http://schemas.openxmlformats.org/officeDocument/2006/math" xmlns="" val="1"/>
+              <ma14:wrappingTextBoxFlag xmlns="" xmlns:m="http://schemas.openxmlformats.org/officeDocument/2006/math" xmlns:a14="http://schemas.microsoft.com/office/drawing/2010/main" xmlns:ma14="http://schemas.microsoft.com/office/mac/drawingml/2011/main" val="1"/>
             </a:ext>
           </a:extLst>
         </p:spPr>
@@ -24506,7 +24530,7 @@
             </a:ln>
             <a:extLst>
               <a:ext uri="{C572A759-6A51-4108-AA02-DFA0A04FC94B}">
-                <ma14:wrappingTextBoxFlag xmlns:ma14="http://schemas.microsoft.com/office/mac/drawingml/2011/main" xmlns:a14="http://schemas.microsoft.com/office/drawing/2010/main" xmlns:m="http://schemas.openxmlformats.org/officeDocument/2006/math" xmlns="" val="1"/>
+                <ma14:wrappingTextBoxFlag xmlns="" xmlns:m="http://schemas.openxmlformats.org/officeDocument/2006/math" xmlns:a14="http://schemas.microsoft.com/office/drawing/2010/main" xmlns:ma14="http://schemas.microsoft.com/office/mac/drawingml/2011/main" val="1"/>
               </a:ext>
             </a:extLst>
           </p:spPr>
@@ -29015,7 +29039,7 @@
           </a:ln>
           <a:extLst>
             <a:ext uri="{C572A759-6A51-4108-AA02-DFA0A04FC94B}">
-              <ma14:wrappingTextBoxFlag xmlns:ma14="http://schemas.microsoft.com/office/mac/drawingml/2011/main" xmlns:a14="http://schemas.microsoft.com/office/drawing/2010/main" xmlns:m="http://schemas.openxmlformats.org/officeDocument/2006/math" xmlns="" val="1"/>
+              <ma14:wrappingTextBoxFlag xmlns="" xmlns:m="http://schemas.openxmlformats.org/officeDocument/2006/math" xmlns:a14="http://schemas.microsoft.com/office/drawing/2010/main" xmlns:ma14="http://schemas.microsoft.com/office/mac/drawingml/2011/main" val="1"/>
             </a:ext>
           </a:extLst>
         </p:spPr>
@@ -29380,7 +29404,7 @@
           </a:ln>
           <a:extLst>
             <a:ext uri="{C572A759-6A51-4108-AA02-DFA0A04FC94B}">
-              <ma14:wrappingTextBoxFlag xmlns:ma14="http://schemas.microsoft.com/office/mac/drawingml/2011/main" xmlns:a14="http://schemas.microsoft.com/office/drawing/2010/main" xmlns:m="http://schemas.openxmlformats.org/officeDocument/2006/math" xmlns="" val="1"/>
+              <ma14:wrappingTextBoxFlag xmlns="" xmlns:m="http://schemas.openxmlformats.org/officeDocument/2006/math" xmlns:a14="http://schemas.microsoft.com/office/drawing/2010/main" xmlns:ma14="http://schemas.microsoft.com/office/mac/drawingml/2011/main" val="1"/>
             </a:ext>
           </a:extLst>
         </p:spPr>
@@ -29451,7 +29475,7 @@
             </a:r>
             <a:r>
               <a:rPr lang="en-US" dirty="0"/>
-              <a:t> the specification?</a:t>
+              <a:t> the specification (Beyonce rule)</a:t>
             </a:r>
             <a:endParaRPr dirty="0"/>
           </a:p>
@@ -29470,7 +29494,7 @@
         <p:spPr>
           <a:xfrm>
             <a:off x="838199" y="1500160"/>
-            <a:ext cx="8574741" cy="4351338"/>
+            <a:ext cx="9643947" cy="4351338"/>
           </a:xfrm>
           <a:prstGeom prst="rect">
             <a:avLst/>
@@ -29617,7 +29641,7 @@
           </a:ln>
           <a:extLst>
             <a:ext uri="{C572A759-6A51-4108-AA02-DFA0A04FC94B}">
-              <ma14:wrappingTextBoxFlag xmlns:ma14="http://schemas.microsoft.com/office/mac/drawingml/2011/main" xmlns:a14="http://schemas.microsoft.com/office/drawing/2010/main" xmlns:m="http://schemas.openxmlformats.org/officeDocument/2006/math" xmlns="" val="1"/>
+              <ma14:wrappingTextBoxFlag xmlns="" xmlns:m="http://schemas.openxmlformats.org/officeDocument/2006/math" xmlns:a14="http://schemas.microsoft.com/office/drawing/2010/main" xmlns:ma14="http://schemas.microsoft.com/office/mac/drawingml/2011/main" val="1"/>
             </a:ext>
           </a:extLst>
         </p:spPr>
@@ -30085,7 +30109,7 @@
           </a:ln>
           <a:extLst>
             <a:ext uri="{C572A759-6A51-4108-AA02-DFA0A04FC94B}">
-              <ma14:wrappingTextBoxFlag xmlns:ma14="http://schemas.microsoft.com/office/mac/drawingml/2011/main" xmlns:a14="http://schemas.microsoft.com/office/drawing/2010/main" xmlns:m="http://schemas.openxmlformats.org/officeDocument/2006/math" xmlns="" val="1"/>
+              <ma14:wrappingTextBoxFlag xmlns="" xmlns:m="http://schemas.openxmlformats.org/officeDocument/2006/math" xmlns:a14="http://schemas.microsoft.com/office/drawing/2010/main" xmlns:ma14="http://schemas.microsoft.com/office/mac/drawingml/2011/main" val="1"/>
             </a:ext>
           </a:extLst>
         </p:spPr>
@@ -30577,7 +30601,7 @@
           </a:ln>
           <a:extLst>
             <a:ext uri="{C572A759-6A51-4108-AA02-DFA0A04FC94B}">
-              <ma14:wrappingTextBoxFlag xmlns="" xmlns:m="http://schemas.openxmlformats.org/officeDocument/2006/math" xmlns:a14="http://schemas.microsoft.com/office/drawing/2010/main" xmlns:ma14="http://schemas.microsoft.com/office/mac/drawingml/2011/main" val="1"/>
+              <ma14:wrappingTextBoxFlag xmlns:ma14="http://schemas.microsoft.com/office/mac/drawingml/2011/main" xmlns:a14="http://schemas.microsoft.com/office/drawing/2010/main" xmlns:m="http://schemas.openxmlformats.org/officeDocument/2006/math" xmlns="" val="1"/>
             </a:ext>
           </a:extLst>
         </p:spPr>
@@ -31233,9 +31257,16 @@
             <p:ph idx="1"/>
           </p:nvPr>
         </p:nvSpPr>
-        <p:spPr/>
+        <p:spPr>
+          <a:xfrm>
+            <a:off x="838199" y="1500160"/>
+            <a:ext cx="8383859" cy="4351338"/>
+          </a:xfrm>
+        </p:spPr>
         <p:txBody>
-          <a:bodyPr/>
+          <a:bodyPr>
+            <a:normAutofit lnSpcReduction="10000"/>
+          </a:bodyPr>
           <a:lstStyle/>
           <a:p>
             <a:r>
@@ -31269,6 +31300,18 @@
           </a:p>
           <a:p>
             <a:endParaRPr lang="en-US" dirty="0"/>
+          </a:p>
+          <a:p>
+            <a:pPr marL="0" indent="0">
+              <a:buNone/>
+            </a:pPr>
+            <a:r>
+              <a:rPr lang="en-US" i="1" dirty="0"/>
+              <a:t>Nevertheless, we start writing tests in TDD</a:t>
+            </a:r>
+          </a:p>
+          <a:p>
+            <a:endParaRPr lang="en-US" i="1" dirty="0"/>
           </a:p>
         </p:txBody>
       </p:sp>

</xml_diff>